<commit_message>
docs(contest): refresh Build Week slides
</commit_message>
<xml_diff>
--- a/docs/build-week-2026-judge-brief.pptx
+++ b/docs/build-week-2026-judge-brief.pptx
@@ -2,20 +2,20 @@
 <file path=ppt/presentation.xml><?xml version="1.0" encoding="utf-8"?>
 <p:presentation xmlns:p="http://schemas.openxmlformats.org/presentationml/2006/main">
   <p:sldMasterIdLst>
-    <p:sldMasterId xmlns:r="http://schemas.openxmlformats.org/officeDocument/2006/relationships" id="2147483648" r:id="R7de6020ebd2c4bf7"/>
+    <p:sldMasterId xmlns:r="http://schemas.openxmlformats.org/officeDocument/2006/relationships" id="2147483648" r:id="Rbb798742985f492f"/>
   </p:sldMasterIdLst>
   <p:notesMasterIdLst>
-    <p:notesMasterId xmlns:r="http://schemas.openxmlformats.org/officeDocument/2006/relationships" r:id="R1111a9ea1451430d"/>
+    <p:notesMasterId xmlns:r="http://schemas.openxmlformats.org/officeDocument/2006/relationships" r:id="R1852ed211a0d4107"/>
   </p:notesMasterIdLst>
   <p:sldIdLst>
-    <p:sldId xmlns:r="http://schemas.openxmlformats.org/officeDocument/2006/relationships" id="256" r:id="R51392f084ec54e65"/>
-    <p:sldId xmlns:r="http://schemas.openxmlformats.org/officeDocument/2006/relationships" id="257" r:id="R12961ae341554ece"/>
-    <p:sldId xmlns:r="http://schemas.openxmlformats.org/officeDocument/2006/relationships" id="258" r:id="R5a21a53e8c2e4139"/>
-    <p:sldId xmlns:r="http://schemas.openxmlformats.org/officeDocument/2006/relationships" id="259" r:id="R08f2083751e446aa"/>
-    <p:sldId xmlns:r="http://schemas.openxmlformats.org/officeDocument/2006/relationships" id="260" r:id="R23de2ccc508b462c"/>
-    <p:sldId xmlns:r="http://schemas.openxmlformats.org/officeDocument/2006/relationships" id="261" r:id="R746ec67ea3644a65"/>
-    <p:sldId xmlns:r="http://schemas.openxmlformats.org/officeDocument/2006/relationships" id="262" r:id="R442ec417f9534494"/>
-    <p:sldId xmlns:r="http://schemas.openxmlformats.org/officeDocument/2006/relationships" id="263" r:id="R9db67234e5494ce6"/>
+    <p:sldId xmlns:r="http://schemas.openxmlformats.org/officeDocument/2006/relationships" id="256" r:id="R818f0110bb524ae1"/>
+    <p:sldId xmlns:r="http://schemas.openxmlformats.org/officeDocument/2006/relationships" id="257" r:id="R4e5e48bf29ee4af6"/>
+    <p:sldId xmlns:r="http://schemas.openxmlformats.org/officeDocument/2006/relationships" id="258" r:id="R64eb8ba8f6724055"/>
+    <p:sldId xmlns:r="http://schemas.openxmlformats.org/officeDocument/2006/relationships" id="259" r:id="R8eae8ca0dc5b40f2"/>
+    <p:sldId xmlns:r="http://schemas.openxmlformats.org/officeDocument/2006/relationships" id="260" r:id="Rbfa2860ab5c2490f"/>
+    <p:sldId xmlns:r="http://schemas.openxmlformats.org/officeDocument/2006/relationships" id="261" r:id="R77a2ff7098614840"/>
+    <p:sldId xmlns:r="http://schemas.openxmlformats.org/officeDocument/2006/relationships" id="262" r:id="R3ff825088af94077"/>
+    <p:sldId xmlns:r="http://schemas.openxmlformats.org/officeDocument/2006/relationships" id="263" r:id="R0e6c2c1b670a44ac"/>
   </p:sldIdLst>
   <p:sldSz cx="12192000" cy="6858000"/>
   <p:notesSz cx="6858000" cy="9144000"/>
@@ -1070,7 +1070,7 @@
   </p:cSld>
   <p:clrMap bg1="lt1" tx1="dk1" bg2="lt2" tx2="dk2" accent1="accent1" accent2="accent2" accent3="accent3" accent4="accent4" accent5="accent5" accent6="accent6" hlink="hlink" folHlink="folHlink"/>
   <p:sldLayoutIdLst>
-    <p:sldLayoutId xmlns:r="http://schemas.openxmlformats.org/officeDocument/2006/relationships" id="2147483649" r:id="Rca9f622ee1a3460a"/>
+    <p:sldLayoutId xmlns:r="http://schemas.openxmlformats.org/officeDocument/2006/relationships" id="2147483649" r:id="R93fd041c17f8425e"/>
   </p:sldLayoutIdLst>
   <p:txStyles>
     <p:titleStyle>
@@ -3571,7 +3571,7 @@
                 <a:ea typeface="Georgia"/>
                 <a:cs typeface="Georgia"/>
               </a:rPr>
-              <a:t>Reading and writing stay connected.</a:t>
+              <a:t>A highlight becomes a citation.</a:t>
             </a:r>
           </a:p>
         </p:txBody>
@@ -3633,7 +3633,7 @@
                 <a:ea typeface="Inter"/>
                 <a:cs typeface="Inter"/>
               </a:rPr>
-              <a:t>Portable Markdown, a live scientific preview, and exact PDF annotations remain directly navigable.</a:t>
+              <a:t>Select a PDF passage, save the evidence, then insert its source and page at the remembered manuscript caret.</a:t>
             </a:r>
           </a:p>
         </p:txBody>
@@ -3710,28 +3710,26 @@
       </p:sp>
       <p:pic>
         <p:nvPicPr>
-          <p:cNvPr id="21" name=""/>
+          <p:cNvPr id="23" name=""/>
           <p:cNvPicPr>
             <a:picLocks xmlns:a="http://schemas.openxmlformats.org/drawingml/2006/main" noChangeAspect="1"/>
           </p:cNvPicPr>
           <p:nvPr/>
         </p:nvPicPr>
         <p:blipFill>
-          <a:blip xmlns:r="http://schemas.openxmlformats.org/officeDocument/2006/relationships" xmlns:a="http://schemas.openxmlformats.org/drawingml/2006/main" r:embed="R1ff28ca1634640f0"/>
+          <a:blip xmlns:r="http://schemas.openxmlformats.org/officeDocument/2006/relationships" xmlns:a="http://schemas.openxmlformats.org/drawingml/2006/main" r:embed="R47125e6e39af4334"/>
           <a:srcRect xmlns:a="http://schemas.openxmlformats.org/drawingml/2006/main" l="0" t="6063" r="0" b="6063"/>
           <a:stretch xmlns:a="http://schemas.openxmlformats.org/drawingml/2006/main">
             <a:fillRect l="0" t="0" r="0" b="0"/>
           </a:stretch>
         </p:blipFill>
         <p:spPr>
-          <a:xfrm xmlns:a="http://schemas.openxmlformats.org/drawingml/2006/main">
+          <a:xfrm xmlns:a="http://schemas.openxmlformats.org/drawingml/2006/main" flipH="0" flipV="0">
             <a:off x="742950" y="2286000"/>
             <a:ext cx="5105400" cy="2990850"/>
           </a:xfrm>
           <a:prstGeom xmlns:a="http://schemas.openxmlformats.org/drawingml/2006/main" prst="roundRect">
-            <a:avLst>
-              <a:gd name="adj" fmla="val 3822"/>
-            </a:avLst>
+            <a:avLst/>
           </a:prstGeom>
         </p:spPr>
       </p:pic>
@@ -3807,28 +3805,26 @@
       </p:sp>
       <p:pic>
         <p:nvPicPr>
-          <p:cNvPr id="24" name=""/>
+          <p:cNvPr id="26" name=""/>
           <p:cNvPicPr>
             <a:picLocks xmlns:a="http://schemas.openxmlformats.org/drawingml/2006/main" noChangeAspect="1"/>
           </p:cNvPicPr>
           <p:nvPr/>
         </p:nvPicPr>
         <p:blipFill>
-          <a:blip xmlns:r="http://schemas.openxmlformats.org/officeDocument/2006/relationships" xmlns:a="http://schemas.openxmlformats.org/drawingml/2006/main" r:embed="R013597c815684316"/>
+          <a:blip xmlns:r="http://schemas.openxmlformats.org/officeDocument/2006/relationships" xmlns:a="http://schemas.openxmlformats.org/drawingml/2006/main" r:embed="R0385f638cdd04649"/>
           <a:srcRect xmlns:a="http://schemas.openxmlformats.org/drawingml/2006/main" l="0" t="6063" r="0" b="6063"/>
           <a:stretch xmlns:a="http://schemas.openxmlformats.org/drawingml/2006/main">
             <a:fillRect l="0" t="0" r="0" b="0"/>
           </a:stretch>
         </p:blipFill>
         <p:spPr>
-          <a:xfrm xmlns:a="http://schemas.openxmlformats.org/drawingml/2006/main">
+          <a:xfrm xmlns:a="http://schemas.openxmlformats.org/drawingml/2006/main" flipH="0" flipV="0">
             <a:off x="6343650" y="2286000"/>
             <a:ext cx="5105400" cy="2990850"/>
           </a:xfrm>
           <a:prstGeom xmlns:a="http://schemas.openxmlformats.org/drawingml/2006/main" prst="roundRect">
-            <a:avLst>
-              <a:gd name="adj" fmla="val 3822"/>
-            </a:avLst>
+            <a:avLst/>
           </a:prstGeom>
         </p:spPr>
       </p:pic>
@@ -3889,7 +3885,7 @@
                 <a:ea typeface="Inter"/>
                 <a:cs typeface="Inter"/>
               </a:rPr>
-              <a:t>AUTHORING  ·  CANONICAL MARKDOWN + LIVE PREVIEW</a:t>
+              <a:t>WRITE  ·  CANONICAL MARKDOWN + LIVE PREVIEW</a:t>
             </a:r>
           </a:p>
         </p:txBody>
@@ -3951,7 +3947,7 @@
                 <a:ea typeface="Inter"/>
                 <a:cs typeface="Inter"/>
               </a:rPr>
-              <a:t>READING  ·  PAGE GEOMETRY + PRIVATE NOTE</a:t>
+              <a:t>EVIDENCE  ·  HIGHLIGHT + PAGE-AWARE CITATION</a:t>
             </a:r>
           </a:p>
         </p:txBody>
@@ -4469,21 +4465,19 @@
           <p:nvPr/>
         </p:nvPicPr>
         <p:blipFill>
-          <a:blip xmlns:r="http://schemas.openxmlformats.org/officeDocument/2006/relationships" xmlns:a="http://schemas.openxmlformats.org/drawingml/2006/main" r:embed="Rb2af975866aa4f70"/>
+          <a:blip xmlns:r="http://schemas.openxmlformats.org/officeDocument/2006/relationships" xmlns:a="http://schemas.openxmlformats.org/drawingml/2006/main" r:embed="R2be71dcdfe5a4c73"/>
           <a:srcRect xmlns:a="http://schemas.openxmlformats.org/drawingml/2006/main" l="4282" t="0" r="4282" b="0"/>
           <a:stretch xmlns:a="http://schemas.openxmlformats.org/drawingml/2006/main">
             <a:fillRect l="0" t="0" r="0" b="0"/>
           </a:stretch>
         </p:blipFill>
         <p:spPr>
-          <a:xfrm xmlns:a="http://schemas.openxmlformats.org/drawingml/2006/main">
+          <a:xfrm xmlns:a="http://schemas.openxmlformats.org/drawingml/2006/main" flipH="0" flipV="0">
             <a:off x="4838700" y="1028700"/>
             <a:ext cx="6610350" cy="4819650"/>
           </a:xfrm>
           <a:prstGeom xmlns:a="http://schemas.openxmlformats.org/drawingml/2006/main" prst="roundRect">
-            <a:avLst>
-              <a:gd name="adj" fmla="val 2372"/>
-            </a:avLst>
+            <a:avLst/>
           </a:prstGeom>
         </p:spPr>
       </p:pic>
@@ -4743,28 +4737,26 @@
       </p:sp>
       <p:pic>
         <p:nvPicPr>
-          <p:cNvPr id="16" name=""/>
+          <p:cNvPr id="17" name=""/>
           <p:cNvPicPr>
             <a:picLocks xmlns:a="http://schemas.openxmlformats.org/drawingml/2006/main" noChangeAspect="1"/>
           </p:cNvPicPr>
           <p:nvPr/>
         </p:nvPicPr>
         <p:blipFill>
-          <a:blip xmlns:r="http://schemas.openxmlformats.org/officeDocument/2006/relationships" xmlns:a="http://schemas.openxmlformats.org/drawingml/2006/main" r:embed="R557da4c8f8394c90"/>
+          <a:blip xmlns:r="http://schemas.openxmlformats.org/officeDocument/2006/relationships" xmlns:a="http://schemas.openxmlformats.org/drawingml/2006/main" r:embed="R2707c2a9efc540bb"/>
           <a:srcRect xmlns:a="http://schemas.openxmlformats.org/drawingml/2006/main" l="3168" t="0" r="3168" b="0"/>
           <a:stretch xmlns:a="http://schemas.openxmlformats.org/drawingml/2006/main">
             <a:fillRect l="0" t="0" r="0" b="0"/>
           </a:stretch>
         </p:blipFill>
         <p:spPr>
-          <a:xfrm xmlns:a="http://schemas.openxmlformats.org/drawingml/2006/main">
+          <a:xfrm xmlns:a="http://schemas.openxmlformats.org/drawingml/2006/main" flipH="0" flipV="0">
             <a:off x="742950" y="1123950"/>
             <a:ext cx="6477000" cy="4610100"/>
           </a:xfrm>
           <a:prstGeom xmlns:a="http://schemas.openxmlformats.org/drawingml/2006/main" prst="roundRect">
-            <a:avLst>
-              <a:gd name="adj" fmla="val 2479"/>
-            </a:avLst>
+            <a:avLst/>
           </a:prstGeom>
         </p:spPr>
       </p:pic>
@@ -5481,7 +5473,7 @@
                 <a:ea typeface="Inter"/>
                 <a:cs typeface="Inter"/>
               </a:rPr>
-              <a:t>Scoped collaboration and rich runtime state end in ordinary, recoverable research artifacts.</a:t>
+              <a:t>Members can open linked PDFs. Public links cannot; raw bibliography stays behind interoperability.</a:t>
             </a:r>
           </a:p>
         </p:txBody>
@@ -5558,28 +5550,26 @@
       </p:sp>
       <p:pic>
         <p:nvPicPr>
-          <p:cNvPr id="21" name=""/>
+          <p:cNvPr id="23" name=""/>
           <p:cNvPicPr>
             <a:picLocks xmlns:a="http://schemas.openxmlformats.org/drawingml/2006/main" noChangeAspect="1"/>
           </p:cNvPicPr>
           <p:nvPr/>
         </p:nvPicPr>
         <p:blipFill>
-          <a:blip xmlns:r="http://schemas.openxmlformats.org/officeDocument/2006/relationships" xmlns:a="http://schemas.openxmlformats.org/drawingml/2006/main" r:embed="R6cb66d3f205b42b7"/>
+          <a:blip xmlns:r="http://schemas.openxmlformats.org/officeDocument/2006/relationships" xmlns:a="http://schemas.openxmlformats.org/drawingml/2006/main" r:embed="R5e2936684a2f4386"/>
           <a:srcRect xmlns:a="http://schemas.openxmlformats.org/drawingml/2006/main" l="0" t="6063" r="0" b="6063"/>
           <a:stretch xmlns:a="http://schemas.openxmlformats.org/drawingml/2006/main">
             <a:fillRect l="0" t="0" r="0" b="0"/>
           </a:stretch>
         </p:blipFill>
         <p:spPr>
-          <a:xfrm xmlns:a="http://schemas.openxmlformats.org/drawingml/2006/main">
+          <a:xfrm xmlns:a="http://schemas.openxmlformats.org/drawingml/2006/main" flipH="0" flipV="0">
             <a:off x="742950" y="2286000"/>
             <a:ext cx="5105400" cy="2990850"/>
           </a:xfrm>
           <a:prstGeom xmlns:a="http://schemas.openxmlformats.org/drawingml/2006/main" prst="roundRect">
-            <a:avLst>
-              <a:gd name="adj" fmla="val 3822"/>
-            </a:avLst>
+            <a:avLst/>
           </a:prstGeom>
         </p:spPr>
       </p:pic>
@@ -5655,28 +5645,26 @@
       </p:sp>
       <p:pic>
         <p:nvPicPr>
-          <p:cNvPr id="24" name=""/>
+          <p:cNvPr id="26" name=""/>
           <p:cNvPicPr>
             <a:picLocks xmlns:a="http://schemas.openxmlformats.org/drawingml/2006/main" noChangeAspect="1"/>
           </p:cNvPicPr>
           <p:nvPr/>
         </p:nvPicPr>
         <p:blipFill>
-          <a:blip xmlns:r="http://schemas.openxmlformats.org/officeDocument/2006/relationships" xmlns:a="http://schemas.openxmlformats.org/drawingml/2006/main" r:embed="Rf7c1707e03f9423e"/>
+          <a:blip xmlns:r="http://schemas.openxmlformats.org/officeDocument/2006/relationships" xmlns:a="http://schemas.openxmlformats.org/drawingml/2006/main" r:embed="R0703cfbf2ece4f28"/>
           <a:srcRect xmlns:a="http://schemas.openxmlformats.org/drawingml/2006/main" l="0" t="6063" r="0" b="6063"/>
           <a:stretch xmlns:a="http://schemas.openxmlformats.org/drawingml/2006/main">
             <a:fillRect l="0" t="0" r="0" b="0"/>
           </a:stretch>
         </p:blipFill>
         <p:spPr>
-          <a:xfrm xmlns:a="http://schemas.openxmlformats.org/drawingml/2006/main">
+          <a:xfrm xmlns:a="http://schemas.openxmlformats.org/drawingml/2006/main" flipH="0" flipV="0">
             <a:off x="6343650" y="2286000"/>
             <a:ext cx="5105400" cy="2990850"/>
           </a:xfrm>
           <a:prstGeom xmlns:a="http://schemas.openxmlformats.org/drawingml/2006/main" prst="roundRect">
-            <a:avLst>
-              <a:gd name="adj" fmla="val 3822"/>
-            </a:avLst>
+            <a:avLst/>
           </a:prstGeom>
         </p:spPr>
       </p:pic>
@@ -5737,7 +5725,7 @@
                 <a:ea typeface="Inter"/>
                 <a:cs typeface="Inter"/>
               </a:rPr>
-              <a:t>COLLABORATE  ·  SCOPED READ OR EDIT LINKS</a:t>
+              <a:t>SHARE  ·  LINKS WITHOUT PRIVATE PDF ACCESS</a:t>
             </a:r>
           </a:p>
         </p:txBody>
@@ -5799,7 +5787,7 @@
                 <a:ea typeface="Inter"/>
                 <a:cs typeface="Inter"/>
               </a:rPr>
-              <a:t>EXPORT  ·  PDF, LATEX, MARKDOWN, BIBTEX, SOURCE</a:t>
+              <a:t>EXPORT  ·  PRIMARY OUTPUTS, BIBLIOGRAPHY ON DEMAND</a:t>
             </a:r>
           </a:p>
         </p:txBody>
@@ -6467,7 +6455,7 @@
                 <a:ea typeface="Inter"/>
                 <a:cs typeface="Inter"/>
               </a:rPr>
-              <a:t>REVIEWED RANGE · JULY 13-19</a:t>
+              <a:t>FINAL REVIEWED RANGE · JULY 13–19</a:t>
             </a:r>
           </a:p>
         </p:txBody>
@@ -6591,7 +6579,7 @@
                 <a:ea typeface="Inter"/>
                 <a:cs typeface="Inter"/>
               </a:rPr>
-              <a:t>- Unified research context and evidence map</a:t>
+              <a:t>- Evidence map and independent reviews</a:t>
             </a:r>
           </a:p>
           <a:p xmlns:a="http://schemas.openxmlformats.org/drawingml/2006/main">
@@ -6618,7 +6606,7 @@
                 <a:ea typeface="Inter"/>
                 <a:cs typeface="Inter"/>
               </a:rPr>
-              <a:t>- Evidence-backed claims and typed model tasks</a:t>
+              <a:t>- Highlight citation and PDF highlight import</a:t>
             </a:r>
           </a:p>
           <a:p xmlns:a="http://schemas.openxmlformats.org/drawingml/2006/main">
@@ -6645,7 +6633,7 @@
                 <a:ea typeface="Inter"/>
                 <a:cs typeface="Inter"/>
               </a:rPr>
-              <a:t>- Scoped sharing, imports, exports, and recovery</a:t>
+              <a:t>- Member PDF access; never public links</a:t>
             </a:r>
           </a:p>
           <a:p xmlns:a="http://schemas.openxmlformats.org/drawingml/2006/main">
@@ -6672,7 +6660,7 @@
                 <a:ea typeface="Inter"/>
                 <a:cs typeface="Inter"/>
               </a:rPr>
-              <a:t>- Independent reviews plus browser audits</a:t>
+              <a:t>- BibTeX only at interoperability boundaries</a:t>
             </a:r>
           </a:p>
         </p:txBody>
@@ -6767,7 +6755,7 @@
                 <a:ea typeface="Fira Code"/>
                 <a:cs typeface="Fira Code"/>
               </a:rPr>
-              <a:t>CORE PRODUCT RANGE  e6a7bdf..99f51e5</a:t>
+              <a:t>CORE PRODUCT RANGE  e6a7bdf..c8f0986</a:t>
             </a:r>
           </a:p>
         </p:txBody>
@@ -6829,7 +6817,7 @@
                 <a:ea typeface="Fira Code"/>
                 <a:cs typeface="Fira Code"/>
               </a:rPr>
-              <a:t>798 UNIT  |  116 WORKERS RUNTIME  |  65 BROWSER TESTS</a:t>
+              <a:t>808 UNIT  |  117 WORKERS RUNTIME  |  65 BROWSER TESTS</a:t>
             </a:r>
           </a:p>
         </p:txBody>
@@ -7377,7 +7365,7 @@
                 <a:ea typeface="Inter"/>
                 <a:cs typeface="Inter"/>
               </a:rPr>
-              <a:t>Codex inspected the existing system, proposed focused changes, implemented features, added tests, and repeated browser-based UI reviews.</a:t>
+              <a:t>Codex inspected the live system, implemented scoped refinements, added tests, and repeated browser reviews through the final snapshot.</a:t>
             </a:r>
           </a:p>
         </p:txBody>
@@ -7531,9 +7519,9 @@
                 <a:latin typeface="Georgia"/>
                 <a:ea typeface="Georgia"/>
                 <a:cs typeface="Georgia"/>
-                <a:hlinkClick xmlns:r="http://schemas.openxmlformats.org/officeDocument/2006/relationships" r:id="Rfaacbd575e664daa"/>
-              </a:rPr>
-              <a:t>github.com/bebraw/kirjolab</a:t>
+                <a:hlinkClick xmlns:r="http://schemas.openxmlformats.org/officeDocument/2006/relationships" r:id="Rb05af696cf5b48fa"/>
+              </a:rPr>
+              <a:t>Open the public snapshot</a:t>
             </a:r>
           </a:p>
         </p:txBody>
@@ -7594,7 +7582,7 @@
                 <a:latin typeface="Georgia"/>
                 <a:ea typeface="Georgia"/>
                 <a:cs typeface="Georgia"/>
-                <a:hlinkClick xmlns:r="http://schemas.openxmlformats.org/officeDocument/2006/relationships" r:id="Rb5f5a618fd154170"/>
+                <a:hlinkClick xmlns:r="http://schemas.openxmlformats.org/officeDocument/2006/relationships" r:id="Rb56ddb1017b34980"/>
               </a:rPr>
               <a:t>Open the judge walkthrough</a:t>
             </a:r>

</xml_diff>